<commit_message>
5 march instance variable, methods and state variables and methods
</commit_message>
<xml_diff>
--- a/13.class_and_objects_4_and_5_mar/OOP_Python_PPTX_Part2.pptx
+++ b/13.class_and_objects_4_and_5_mar/OOP_Python_PPTX_Part2.pptx
@@ -79,25 +79,7 @@
               <a:rPr b="0" lang="en-IN" sz="4400" spc="-1" strike="noStrike">
                 <a:latin typeface="Arial"/>
               </a:rPr>
-              <a:t>Click to </a:t>
-            </a:r>
-            <a:r>
-              <a:rPr b="0" lang="en-IN" sz="4400" spc="-1" strike="noStrike">
-                <a:latin typeface="Arial"/>
-              </a:rPr>
-              <a:t>move </a:t>
-            </a:r>
-            <a:r>
-              <a:rPr b="0" lang="en-IN" sz="4400" spc="-1" strike="noStrike">
-                <a:latin typeface="Arial"/>
-              </a:rPr>
-              <a:t>the </a:t>
-            </a:r>
-            <a:r>
-              <a:rPr b="0" lang="en-IN" sz="4400" spc="-1" strike="noStrike">
-                <a:latin typeface="Arial"/>
-              </a:rPr>
-              <a:t>slide</a:t>
+              <a:t>Click to move the slide</a:t>
             </a:r>
             <a:endParaRPr b="0" lang="en-IN" sz="4400" spc="-1" strike="noStrike">
               <a:latin typeface="Arial"/>
@@ -137,13 +119,13 @@
               <a:rPr b="0" lang="en-IN" sz="2000" spc="-1" strike="noStrike">
                 <a:latin typeface="Arial"/>
               </a:rPr>
-              <a:t>Click to edit the </a:t>
+              <a:t>Click to edit the notes </a:t>
             </a:r>
             <a:r>
               <a:rPr b="0" lang="en-IN" sz="2000" spc="-1" strike="noStrike">
                 <a:latin typeface="Arial"/>
               </a:rPr>
-              <a:t>notes format</a:t>
+              <a:t>format</a:t>
             </a:r>
             <a:endParaRPr b="0" lang="en-IN" sz="2000" spc="-1" strike="noStrike">
               <a:latin typeface="Arial"/>
@@ -328,7 +310,7 @@
             <a:pPr algn="r">
               <a:buNone/>
             </a:pPr>
-            <a:fld id="{28CE6E5F-71D2-4DA2-A560-B8CFDDF50140}" type="slidenum">
+            <a:fld id="{54F84539-1EDB-4B27-A833-0BE8582AC2F1}" type="slidenum">
               <a:rPr b="0" lang="en-IN" sz="1400" spc="-1" strike="noStrike">
                 <a:latin typeface="Times New Roman"/>
               </a:rPr>
@@ -376,7 +358,7 @@
         <p:spPr>
           <a:xfrm>
             <a:off x="685800" y="1143000"/>
-            <a:ext cx="5485320" cy="3085200"/>
+            <a:ext cx="5484960" cy="3084840"/>
           </a:xfrm>
           <a:prstGeom prst="rect">
             <a:avLst/>
@@ -399,7 +381,7 @@
         <p:spPr>
           <a:xfrm>
             <a:off x="685800" y="4400640"/>
-            <a:ext cx="5485320" cy="3599280"/>
+            <a:ext cx="5484960" cy="3598920"/>
           </a:xfrm>
           <a:prstGeom prst="rect">
             <a:avLst/>
@@ -433,7 +415,7 @@
         <p:spPr>
           <a:xfrm>
             <a:off x="3884760" y="8685360"/>
-            <a:ext cx="2970720" cy="457560"/>
+            <a:ext cx="2970360" cy="457200"/>
           </a:xfrm>
           <a:prstGeom prst="rect">
             <a:avLst/>
@@ -469,7 +451,7 @@
               </a:lnSpc>
               <a:buNone/>
             </a:pPr>
-            <a:fld id="{2E391F05-061B-483A-9BF9-C717788B33E9}" type="slidenum">
+            <a:fld id="{50FE304E-7964-456D-B278-9949CD834B1D}" type="slidenum">
               <a:rPr b="0" lang="en-US" sz="1200" spc="-1" strike="noStrike">
                 <a:solidFill>
                   <a:srgbClr val="000000"/>
@@ -520,7 +502,7 @@
         <p:spPr>
           <a:xfrm>
             <a:off x="685800" y="1143000"/>
-            <a:ext cx="5485320" cy="3085200"/>
+            <a:ext cx="5484960" cy="3084840"/>
           </a:xfrm>
           <a:prstGeom prst="rect">
             <a:avLst/>
@@ -543,7 +525,7 @@
         <p:spPr>
           <a:xfrm>
             <a:off x="685800" y="4400640"/>
-            <a:ext cx="5485320" cy="3599280"/>
+            <a:ext cx="5484960" cy="3598920"/>
           </a:xfrm>
           <a:prstGeom prst="rect">
             <a:avLst/>
@@ -577,7 +559,7 @@
         <p:spPr>
           <a:xfrm>
             <a:off x="3884760" y="8685360"/>
-            <a:ext cx="2970720" cy="457560"/>
+            <a:ext cx="2970360" cy="457200"/>
           </a:xfrm>
           <a:prstGeom prst="rect">
             <a:avLst/>
@@ -613,7 +595,7 @@
               </a:lnSpc>
               <a:buNone/>
             </a:pPr>
-            <a:fld id="{E367179D-851F-4174-8F0F-FF1BA90EB125}" type="slidenum">
+            <a:fld id="{CC51B195-DF20-41A7-89C7-C57B9E146B5F}" type="slidenum">
               <a:rPr b="0" lang="en-US" sz="1200" spc="-1" strike="noStrike">
                 <a:solidFill>
                   <a:srgbClr val="000000"/>
@@ -664,7 +646,7 @@
         <p:spPr>
           <a:xfrm>
             <a:off x="685800" y="1143000"/>
-            <a:ext cx="5485320" cy="3085200"/>
+            <a:ext cx="5484960" cy="3084840"/>
           </a:xfrm>
           <a:prstGeom prst="rect">
             <a:avLst/>
@@ -687,7 +669,7 @@
         <p:spPr>
           <a:xfrm>
             <a:off x="685800" y="4400640"/>
-            <a:ext cx="5485320" cy="3599280"/>
+            <a:ext cx="5484960" cy="3598920"/>
           </a:xfrm>
           <a:prstGeom prst="rect">
             <a:avLst/>
@@ -721,7 +703,7 @@
         <p:spPr>
           <a:xfrm>
             <a:off x="3884760" y="8685360"/>
-            <a:ext cx="2970720" cy="457560"/>
+            <a:ext cx="2970360" cy="457200"/>
           </a:xfrm>
           <a:prstGeom prst="rect">
             <a:avLst/>
@@ -757,7 +739,7 @@
               </a:lnSpc>
               <a:buNone/>
             </a:pPr>
-            <a:fld id="{A9BF4FF5-EF1E-4A89-BE43-B1184F228726}" type="slidenum">
+            <a:fld id="{9A8CEA9F-5422-411E-808E-638FA72815BE}" type="slidenum">
               <a:rPr b="0" lang="en-US" sz="1200" spc="-1" strike="noStrike">
                 <a:solidFill>
                   <a:srgbClr val="000000"/>
@@ -808,7 +790,7 @@
         <p:spPr>
           <a:xfrm>
             <a:off x="685800" y="1143000"/>
-            <a:ext cx="5485320" cy="3085200"/>
+            <a:ext cx="5484960" cy="3084840"/>
           </a:xfrm>
           <a:prstGeom prst="rect">
             <a:avLst/>
@@ -831,7 +813,7 @@
         <p:spPr>
           <a:xfrm>
             <a:off x="685800" y="4400640"/>
-            <a:ext cx="5485320" cy="3599280"/>
+            <a:ext cx="5484960" cy="3598920"/>
           </a:xfrm>
           <a:prstGeom prst="rect">
             <a:avLst/>
@@ -865,7 +847,7 @@
         <p:spPr>
           <a:xfrm>
             <a:off x="3884760" y="8685360"/>
-            <a:ext cx="2970720" cy="457560"/>
+            <a:ext cx="2970360" cy="457200"/>
           </a:xfrm>
           <a:prstGeom prst="rect">
             <a:avLst/>
@@ -901,7 +883,7 @@
               </a:lnSpc>
               <a:buNone/>
             </a:pPr>
-            <a:fld id="{79068632-7F77-433B-8F8F-9B8EDFE1F154}" type="slidenum">
+            <a:fld id="{1B4616D8-CE73-4FD0-80DD-70A08CDC5977}" type="slidenum">
               <a:rPr b="0" lang="en-US" sz="1200" spc="-1" strike="noStrike">
                 <a:solidFill>
                   <a:srgbClr val="000000"/>
@@ -952,7 +934,7 @@
         <p:spPr>
           <a:xfrm>
             <a:off x="685800" y="1143000"/>
-            <a:ext cx="5485320" cy="3085200"/>
+            <a:ext cx="5484960" cy="3084840"/>
           </a:xfrm>
           <a:prstGeom prst="rect">
             <a:avLst/>
@@ -975,7 +957,7 @@
         <p:spPr>
           <a:xfrm>
             <a:off x="685800" y="4400640"/>
-            <a:ext cx="5485320" cy="3599280"/>
+            <a:ext cx="5484960" cy="3598920"/>
           </a:xfrm>
           <a:prstGeom prst="rect">
             <a:avLst/>
@@ -1009,7 +991,7 @@
         <p:spPr>
           <a:xfrm>
             <a:off x="3884760" y="8685360"/>
-            <a:ext cx="2970720" cy="457560"/>
+            <a:ext cx="2970360" cy="457200"/>
           </a:xfrm>
           <a:prstGeom prst="rect">
             <a:avLst/>
@@ -1045,7 +1027,7 @@
               </a:lnSpc>
               <a:buNone/>
             </a:pPr>
-            <a:fld id="{8CFDDE8E-E5F1-4039-B652-2D3448298694}" type="slidenum">
+            <a:fld id="{0E3DFBE3-3AF9-4A4C-8DEB-A2A32636D596}" type="slidenum">
               <a:rPr b="0" lang="en-US" sz="1200" spc="-1" strike="noStrike">
                 <a:solidFill>
                   <a:srgbClr val="000000"/>
@@ -1096,7 +1078,7 @@
         <p:spPr>
           <a:xfrm>
             <a:off x="685800" y="1143000"/>
-            <a:ext cx="5485320" cy="3085200"/>
+            <a:ext cx="5484960" cy="3084840"/>
           </a:xfrm>
           <a:prstGeom prst="rect">
             <a:avLst/>
@@ -1119,7 +1101,7 @@
         <p:spPr>
           <a:xfrm>
             <a:off x="685800" y="4400640"/>
-            <a:ext cx="5485320" cy="3599280"/>
+            <a:ext cx="5484960" cy="3598920"/>
           </a:xfrm>
           <a:prstGeom prst="rect">
             <a:avLst/>
@@ -1153,7 +1135,7 @@
         <p:spPr>
           <a:xfrm>
             <a:off x="3884760" y="8685360"/>
-            <a:ext cx="2970720" cy="457560"/>
+            <a:ext cx="2970360" cy="457200"/>
           </a:xfrm>
           <a:prstGeom prst="rect">
             <a:avLst/>
@@ -1189,7 +1171,7 @@
               </a:lnSpc>
               <a:buNone/>
             </a:pPr>
-            <a:fld id="{B75DFE3E-0F19-4844-8850-93BA554E516D}" type="slidenum">
+            <a:fld id="{BB43B179-F7C0-4FB5-886F-BC04EBE35FDB}" type="slidenum">
               <a:rPr b="0" lang="en-US" sz="1200" spc="-1" strike="noStrike">
                 <a:solidFill>
                   <a:srgbClr val="000000"/>
@@ -1240,7 +1222,7 @@
         <p:spPr>
           <a:xfrm>
             <a:off x="685800" y="1143000"/>
-            <a:ext cx="5485320" cy="3085200"/>
+            <a:ext cx="5484960" cy="3084840"/>
           </a:xfrm>
           <a:prstGeom prst="rect">
             <a:avLst/>
@@ -1263,7 +1245,7 @@
         <p:spPr>
           <a:xfrm>
             <a:off x="685800" y="4400640"/>
-            <a:ext cx="5485320" cy="3599280"/>
+            <a:ext cx="5484960" cy="3598920"/>
           </a:xfrm>
           <a:prstGeom prst="rect">
             <a:avLst/>
@@ -1297,7 +1279,7 @@
         <p:spPr>
           <a:xfrm>
             <a:off x="3884760" y="8685360"/>
-            <a:ext cx="2970720" cy="457560"/>
+            <a:ext cx="2970360" cy="457200"/>
           </a:xfrm>
           <a:prstGeom prst="rect">
             <a:avLst/>
@@ -1333,7 +1315,7 @@
               </a:lnSpc>
               <a:buNone/>
             </a:pPr>
-            <a:fld id="{7108C376-3E76-47C8-B7BB-1E6FF63FB3A4}" type="slidenum">
+            <a:fld id="{82FC9BC6-4888-4561-8714-6F5F1BEA95FE}" type="slidenum">
               <a:rPr b="0" lang="en-US" sz="1200" spc="-1" strike="noStrike">
                 <a:solidFill>
                   <a:srgbClr val="000000"/>
@@ -1384,7 +1366,7 @@
         <p:spPr>
           <a:xfrm>
             <a:off x="685800" y="1143000"/>
-            <a:ext cx="5485320" cy="3085200"/>
+            <a:ext cx="5484960" cy="3084840"/>
           </a:xfrm>
           <a:prstGeom prst="rect">
             <a:avLst/>
@@ -1407,7 +1389,7 @@
         <p:spPr>
           <a:xfrm>
             <a:off x="685800" y="4400640"/>
-            <a:ext cx="5485320" cy="3599280"/>
+            <a:ext cx="5484960" cy="3598920"/>
           </a:xfrm>
           <a:prstGeom prst="rect">
             <a:avLst/>
@@ -1441,7 +1423,7 @@
         <p:spPr>
           <a:xfrm>
             <a:off x="3884760" y="8685360"/>
-            <a:ext cx="2970720" cy="457560"/>
+            <a:ext cx="2970360" cy="457200"/>
           </a:xfrm>
           <a:prstGeom prst="rect">
             <a:avLst/>
@@ -1477,7 +1459,7 @@
               </a:lnSpc>
               <a:buNone/>
             </a:pPr>
-            <a:fld id="{F6351858-D041-4204-84A5-9C291E79EE49}" type="slidenum">
+            <a:fld id="{2BA927C0-33E9-44E5-B749-8F0C193DCF16}" type="slidenum">
               <a:rPr b="0" lang="en-US" sz="1200" spc="-1" strike="noStrike">
                 <a:solidFill>
                   <a:srgbClr val="000000"/>
@@ -1528,7 +1510,7 @@
         <p:spPr>
           <a:xfrm>
             <a:off x="685800" y="1143000"/>
-            <a:ext cx="5485320" cy="3085200"/>
+            <a:ext cx="5484960" cy="3084840"/>
           </a:xfrm>
           <a:prstGeom prst="rect">
             <a:avLst/>
@@ -1551,7 +1533,7 @@
         <p:spPr>
           <a:xfrm>
             <a:off x="685800" y="4400640"/>
-            <a:ext cx="5485320" cy="3599280"/>
+            <a:ext cx="5484960" cy="3598920"/>
           </a:xfrm>
           <a:prstGeom prst="rect">
             <a:avLst/>
@@ -1585,7 +1567,7 @@
         <p:spPr>
           <a:xfrm>
             <a:off x="3884760" y="8685360"/>
-            <a:ext cx="2970720" cy="457560"/>
+            <a:ext cx="2970360" cy="457200"/>
           </a:xfrm>
           <a:prstGeom prst="rect">
             <a:avLst/>
@@ -1621,7 +1603,7 @@
               </a:lnSpc>
               <a:buNone/>
             </a:pPr>
-            <a:fld id="{BB38B1B2-E818-47EC-A8A0-3D9067FD5E4A}" type="slidenum">
+            <a:fld id="{878FB772-7CBC-4314-BC8A-3349045BFFE8}" type="slidenum">
               <a:rPr b="0" lang="en-US" sz="1200" spc="-1" strike="noStrike">
                 <a:solidFill>
                   <a:srgbClr val="000000"/>
@@ -1672,7 +1654,7 @@
         <p:spPr>
           <a:xfrm>
             <a:off x="685800" y="1143000"/>
-            <a:ext cx="5485320" cy="3085200"/>
+            <a:ext cx="5484960" cy="3084840"/>
           </a:xfrm>
           <a:prstGeom prst="rect">
             <a:avLst/>
@@ -1695,7 +1677,7 @@
         <p:spPr>
           <a:xfrm>
             <a:off x="685800" y="4400640"/>
-            <a:ext cx="5485320" cy="3599280"/>
+            <a:ext cx="5484960" cy="3598920"/>
           </a:xfrm>
           <a:prstGeom prst="rect">
             <a:avLst/>
@@ -1729,7 +1711,7 @@
         <p:spPr>
           <a:xfrm>
             <a:off x="3884760" y="8685360"/>
-            <a:ext cx="2970720" cy="457560"/>
+            <a:ext cx="2970360" cy="457200"/>
           </a:xfrm>
           <a:prstGeom prst="rect">
             <a:avLst/>
@@ -1765,7 +1747,7 @@
               </a:lnSpc>
               <a:buNone/>
             </a:pPr>
-            <a:fld id="{CE741854-1533-430E-AC37-5D0A99F57026}" type="slidenum">
+            <a:fld id="{7595AFBB-8999-45D3-81E9-F759CC85A40E}" type="slidenum">
               <a:rPr b="0" lang="en-US" sz="1200" spc="-1" strike="noStrike">
                 <a:solidFill>
                   <a:srgbClr val="000000"/>
@@ -1816,7 +1798,7 @@
         <p:spPr>
           <a:xfrm>
             <a:off x="685800" y="1143000"/>
-            <a:ext cx="5485320" cy="3085200"/>
+            <a:ext cx="5484960" cy="3084840"/>
           </a:xfrm>
           <a:prstGeom prst="rect">
             <a:avLst/>
@@ -1839,7 +1821,7 @@
         <p:spPr>
           <a:xfrm>
             <a:off x="685800" y="4400640"/>
-            <a:ext cx="5485320" cy="3599280"/>
+            <a:ext cx="5484960" cy="3598920"/>
           </a:xfrm>
           <a:prstGeom prst="rect">
             <a:avLst/>
@@ -1873,7 +1855,7 @@
         <p:spPr>
           <a:xfrm>
             <a:off x="3884760" y="8685360"/>
-            <a:ext cx="2970720" cy="457560"/>
+            <a:ext cx="2970360" cy="457200"/>
           </a:xfrm>
           <a:prstGeom prst="rect">
             <a:avLst/>
@@ -1909,7 +1891,7 @@
               </a:lnSpc>
               <a:buNone/>
             </a:pPr>
-            <a:fld id="{6011A5F8-0D01-459B-B9EA-68CC0E0E1227}" type="slidenum">
+            <a:fld id="{1BBE1122-1608-4852-B873-99B29C0F5F34}" type="slidenum">
               <a:rPr b="0" lang="en-US" sz="1200" spc="-1" strike="noStrike">
                 <a:solidFill>
                   <a:srgbClr val="000000"/>
@@ -1960,7 +1942,7 @@
         <p:spPr>
           <a:xfrm>
             <a:off x="685800" y="1143000"/>
-            <a:ext cx="5485320" cy="3085200"/>
+            <a:ext cx="5484960" cy="3084840"/>
           </a:xfrm>
           <a:prstGeom prst="rect">
             <a:avLst/>
@@ -1983,7 +1965,7 @@
         <p:spPr>
           <a:xfrm>
             <a:off x="685800" y="4400640"/>
-            <a:ext cx="5485320" cy="3599280"/>
+            <a:ext cx="5484960" cy="3598920"/>
           </a:xfrm>
           <a:prstGeom prst="rect">
             <a:avLst/>
@@ -2017,7 +1999,7 @@
         <p:spPr>
           <a:xfrm>
             <a:off x="3884760" y="8685360"/>
-            <a:ext cx="2970720" cy="457560"/>
+            <a:ext cx="2970360" cy="457200"/>
           </a:xfrm>
           <a:prstGeom prst="rect">
             <a:avLst/>
@@ -2053,7 +2035,7 @@
               </a:lnSpc>
               <a:buNone/>
             </a:pPr>
-            <a:fld id="{3B3A99CF-0BE2-47FC-994F-CEE4840E6258}" type="slidenum">
+            <a:fld id="{0CF94D59-8FC4-44E5-A0B9-FCFE7BF0A46E}" type="slidenum">
               <a:rPr b="0" lang="en-US" sz="1200" spc="-1" strike="noStrike">
                 <a:solidFill>
                   <a:srgbClr val="000000"/>
@@ -2104,7 +2086,7 @@
         <p:spPr>
           <a:xfrm>
             <a:off x="685800" y="1143000"/>
-            <a:ext cx="5485320" cy="3085200"/>
+            <a:ext cx="5484960" cy="3084840"/>
           </a:xfrm>
           <a:prstGeom prst="rect">
             <a:avLst/>
@@ -2127,7 +2109,7 @@
         <p:spPr>
           <a:xfrm>
             <a:off x="685800" y="4400640"/>
-            <a:ext cx="5485320" cy="3599280"/>
+            <a:ext cx="5484960" cy="3598920"/>
           </a:xfrm>
           <a:prstGeom prst="rect">
             <a:avLst/>
@@ -2161,7 +2143,7 @@
         <p:spPr>
           <a:xfrm>
             <a:off x="3884760" y="8685360"/>
-            <a:ext cx="2970720" cy="457560"/>
+            <a:ext cx="2970360" cy="457200"/>
           </a:xfrm>
           <a:prstGeom prst="rect">
             <a:avLst/>
@@ -2197,7 +2179,7 @@
               </a:lnSpc>
               <a:buNone/>
             </a:pPr>
-            <a:fld id="{963C723E-DCB5-421C-88CB-7E43AC94EDB9}" type="slidenum">
+            <a:fld id="{EF5845E8-DD4D-46FB-BEEE-B1E216811484}" type="slidenum">
               <a:rPr b="0" lang="en-US" sz="1200" spc="-1" strike="noStrike">
                 <a:solidFill>
                   <a:srgbClr val="000000"/>
@@ -3801,25 +3783,49 @@
               <a:rPr b="0" lang="en-IN" sz="4400" spc="-1" strike="noStrike">
                 <a:latin typeface="Arial"/>
               </a:rPr>
-              <a:t>Click to </a:t>
+              <a:t>Click </a:t>
             </a:r>
             <a:r>
               <a:rPr b="0" lang="en-IN" sz="4400" spc="-1" strike="noStrike">
                 <a:latin typeface="Arial"/>
               </a:rPr>
-              <a:t>edit the </a:t>
+              <a:t>to </a:t>
             </a:r>
             <a:r>
               <a:rPr b="0" lang="en-IN" sz="4400" spc="-1" strike="noStrike">
                 <a:latin typeface="Arial"/>
               </a:rPr>
-              <a:t>title text </a:t>
+              <a:t>edit </a:t>
             </a:r>
             <a:r>
               <a:rPr b="0" lang="en-IN" sz="4400" spc="-1" strike="noStrike">
                 <a:latin typeface="Arial"/>
               </a:rPr>
-              <a:t>format</a:t>
+              <a:t>the </a:t>
+            </a:r>
+            <a:r>
+              <a:rPr b="0" lang="en-IN" sz="4400" spc="-1" strike="noStrike">
+                <a:latin typeface="Arial"/>
+              </a:rPr>
+              <a:t>title </a:t>
+            </a:r>
+            <a:r>
+              <a:rPr b="0" lang="en-IN" sz="4400" spc="-1" strike="noStrike">
+                <a:latin typeface="Arial"/>
+              </a:rPr>
+              <a:t>text </a:t>
+            </a:r>
+            <a:r>
+              <a:rPr b="0" lang="en-IN" sz="4400" spc="-1" strike="noStrike">
+                <a:latin typeface="Arial"/>
+              </a:rPr>
+              <a:t>form</a:t>
+            </a:r>
+            <a:r>
+              <a:rPr b="0" lang="en-IN" sz="4400" spc="-1" strike="noStrike">
+                <a:latin typeface="Arial"/>
+              </a:rPr>
+              <a:t>at</a:t>
             </a:r>
             <a:endParaRPr b="0" lang="en-IN" sz="4400" spc="-1" strike="noStrike">
               <a:latin typeface="Arial"/>
@@ -4063,7 +4069,7 @@
         <p:spPr>
           <a:xfrm>
             <a:off x="0" y="0"/>
-            <a:ext cx="3473640" cy="5142600"/>
+            <a:ext cx="3473280" cy="5142240"/>
           </a:xfrm>
           <a:prstGeom prst="rect">
             <a:avLst/>
@@ -4094,7 +4100,7 @@
         <p:spPr>
           <a:xfrm>
             <a:off x="3474720" y="0"/>
-            <a:ext cx="53640" cy="5142600"/>
+            <a:ext cx="53280" cy="5142240"/>
           </a:xfrm>
           <a:prstGeom prst="rect">
             <a:avLst/>
@@ -4125,7 +4131,7 @@
         <p:spPr>
           <a:xfrm>
             <a:off x="457200" y="548640"/>
-            <a:ext cx="2376360" cy="2376360"/>
+            <a:ext cx="2376000" cy="2376000"/>
           </a:xfrm>
           <a:prstGeom prst="ellipse">
             <a:avLst/>
@@ -4156,7 +4162,7 @@
         <p:spPr>
           <a:xfrm>
             <a:off x="457200" y="548640"/>
-            <a:ext cx="2376360" cy="2376360"/>
+            <a:ext cx="2376000" cy="2376000"/>
           </a:xfrm>
           <a:prstGeom prst="rect">
             <a:avLst/>
@@ -4211,7 +4217,7 @@
         <p:spPr>
           <a:xfrm>
             <a:off x="274320" y="3108960"/>
-            <a:ext cx="2925000" cy="410400"/>
+            <a:ext cx="2924640" cy="410040"/>
           </a:xfrm>
           <a:prstGeom prst="rect">
             <a:avLst/>
@@ -4242,7 +4248,7 @@
               </a:tabLst>
             </a:pPr>
             <a:r>
-              <a:rPr b="1" lang="en-US" sz="1300" spc="392" strike="noStrike">
+              <a:rPr b="1" lang="en-US" sz="1300" spc="389" strike="noStrike">
                 <a:solidFill>
                   <a:srgbClr val="38bdf8"/>
                 </a:solidFill>
@@ -4266,7 +4272,7 @@
         <p:spPr>
           <a:xfrm>
             <a:off x="3749040" y="457200"/>
-            <a:ext cx="5211000" cy="1370520"/>
+            <a:ext cx="5210640" cy="1370160"/>
           </a:xfrm>
           <a:prstGeom prst="rect">
             <a:avLst/>
@@ -4345,7 +4351,7 @@
         <p:spPr>
           <a:xfrm>
             <a:off x="3749040" y="1874520"/>
-            <a:ext cx="5211000" cy="410400"/>
+            <a:ext cx="5210640" cy="410040"/>
           </a:xfrm>
           <a:prstGeom prst="rect">
             <a:avLst/>
@@ -4400,7 +4406,7 @@
         <p:spPr>
           <a:xfrm>
             <a:off x="3749040" y="2377440"/>
-            <a:ext cx="5211000" cy="35640"/>
+            <a:ext cx="5210640" cy="35280"/>
           </a:xfrm>
           <a:prstGeom prst="rect">
             <a:avLst/>
@@ -4431,7 +4437,7 @@
         <p:spPr>
           <a:xfrm>
             <a:off x="3749040" y="2560320"/>
-            <a:ext cx="5211000" cy="2193480"/>
+            <a:ext cx="5210640" cy="2193120"/>
           </a:xfrm>
           <a:prstGeom prst="rect">
             <a:avLst/>
@@ -4624,7 +4630,7 @@
         <p:spPr>
           <a:xfrm>
             <a:off x="0" y="0"/>
-            <a:ext cx="63000" cy="5142600"/>
+            <a:ext cx="62640" cy="5142240"/>
           </a:xfrm>
           <a:prstGeom prst="rect">
             <a:avLst/>
@@ -4655,7 +4661,7 @@
         <p:spPr>
           <a:xfrm>
             <a:off x="0" y="0"/>
-            <a:ext cx="9142920" cy="712080"/>
+            <a:ext cx="9142560" cy="711720"/>
           </a:xfrm>
           <a:prstGeom prst="rect">
             <a:avLst/>
@@ -4686,7 +4692,7 @@
         <p:spPr>
           <a:xfrm>
             <a:off x="182880" y="0"/>
-            <a:ext cx="7131240" cy="712080"/>
+            <a:ext cx="7130880" cy="711720"/>
           </a:xfrm>
           <a:prstGeom prst="rect">
             <a:avLst/>
@@ -4741,7 +4747,7 @@
         <p:spPr>
           <a:xfrm>
             <a:off x="7589520" y="109800"/>
-            <a:ext cx="1370520" cy="474480"/>
+            <a:ext cx="1370160" cy="474120"/>
           </a:xfrm>
           <a:prstGeom prst="rect">
             <a:avLst/>
@@ -4779,7 +4785,7 @@
         <p:spPr>
           <a:xfrm>
             <a:off x="7589520" y="109800"/>
-            <a:ext cx="1370520" cy="474480"/>
+            <a:ext cx="1370160" cy="474120"/>
           </a:xfrm>
           <a:prstGeom prst="rect">
             <a:avLst/>
@@ -4834,7 +4840,7 @@
         <p:spPr>
           <a:xfrm>
             <a:off x="182880" y="804600"/>
-            <a:ext cx="2833560" cy="1077840"/>
+            <a:ext cx="2833200" cy="1077480"/>
           </a:xfrm>
           <a:prstGeom prst="rect">
             <a:avLst/>
@@ -4872,7 +4878,7 @@
         <p:spPr>
           <a:xfrm>
             <a:off x="182880" y="804600"/>
-            <a:ext cx="2833560" cy="53640"/>
+            <a:ext cx="2833200" cy="53280"/>
           </a:xfrm>
           <a:prstGeom prst="rect">
             <a:avLst/>
@@ -4903,7 +4909,7 @@
         <p:spPr>
           <a:xfrm>
             <a:off x="320040" y="896040"/>
-            <a:ext cx="2559240" cy="346320"/>
+            <a:ext cx="2558880" cy="345960"/>
           </a:xfrm>
           <a:prstGeom prst="rect">
             <a:avLst/>
@@ -4958,7 +4964,7 @@
         <p:spPr>
           <a:xfrm>
             <a:off x="320040" y="1261800"/>
-            <a:ext cx="2559240" cy="501840"/>
+            <a:ext cx="2558880" cy="501480"/>
           </a:xfrm>
           <a:prstGeom prst="rect">
             <a:avLst/>
@@ -5013,7 +5019,7 @@
         <p:spPr>
           <a:xfrm>
             <a:off x="3154680" y="804600"/>
-            <a:ext cx="2833560" cy="1077840"/>
+            <a:ext cx="2833200" cy="1077480"/>
           </a:xfrm>
           <a:prstGeom prst="rect">
             <a:avLst/>
@@ -5051,7 +5057,7 @@
         <p:spPr>
           <a:xfrm>
             <a:off x="3154680" y="804600"/>
-            <a:ext cx="2833560" cy="53640"/>
+            <a:ext cx="2833200" cy="53280"/>
           </a:xfrm>
           <a:prstGeom prst="rect">
             <a:avLst/>
@@ -5082,7 +5088,7 @@
         <p:spPr>
           <a:xfrm>
             <a:off x="3291840" y="896040"/>
-            <a:ext cx="2559240" cy="346320"/>
+            <a:ext cx="2558880" cy="345960"/>
           </a:xfrm>
           <a:prstGeom prst="rect">
             <a:avLst/>
@@ -5137,7 +5143,7 @@
         <p:spPr>
           <a:xfrm>
             <a:off x="3291840" y="1261800"/>
-            <a:ext cx="2559240" cy="501840"/>
+            <a:ext cx="2558880" cy="501480"/>
           </a:xfrm>
           <a:prstGeom prst="rect">
             <a:avLst/>
@@ -5192,7 +5198,7 @@
         <p:spPr>
           <a:xfrm>
             <a:off x="6126480" y="804600"/>
-            <a:ext cx="2833560" cy="1077840"/>
+            <a:ext cx="2833200" cy="1077480"/>
           </a:xfrm>
           <a:prstGeom prst="rect">
             <a:avLst/>
@@ -5230,7 +5236,7 @@
         <p:spPr>
           <a:xfrm>
             <a:off x="6126480" y="804600"/>
-            <a:ext cx="2833560" cy="53640"/>
+            <a:ext cx="2833200" cy="53280"/>
           </a:xfrm>
           <a:prstGeom prst="rect">
             <a:avLst/>
@@ -5261,7 +5267,7 @@
         <p:spPr>
           <a:xfrm>
             <a:off x="6263640" y="896040"/>
-            <a:ext cx="2559240" cy="346320"/>
+            <a:ext cx="2558880" cy="345960"/>
           </a:xfrm>
           <a:prstGeom prst="rect">
             <a:avLst/>
@@ -5316,7 +5322,7 @@
         <p:spPr>
           <a:xfrm>
             <a:off x="6263640" y="1261800"/>
-            <a:ext cx="2559240" cy="501840"/>
+            <a:ext cx="2558880" cy="501480"/>
           </a:xfrm>
           <a:prstGeom prst="rect">
             <a:avLst/>
@@ -5370,8 +5376,8 @@
         </p:nvSpPr>
         <p:spPr>
           <a:xfrm>
-            <a:off x="182880" y="1974960"/>
-            <a:ext cx="5576400" cy="3784320"/>
+            <a:off x="-537120" y="1974960"/>
+            <a:ext cx="5577120" cy="4325040"/>
           </a:xfrm>
           <a:prstGeom prst="rect">
             <a:avLst/>
@@ -5409,7 +5415,7 @@
         <p:spPr>
           <a:xfrm>
             <a:off x="182880" y="1974960"/>
-            <a:ext cx="5668200" cy="254880"/>
+            <a:ext cx="5667840" cy="254520"/>
           </a:xfrm>
           <a:prstGeom prst="rect">
             <a:avLst/>
@@ -5440,7 +5446,7 @@
         <p:spPr>
           <a:xfrm>
             <a:off x="292680" y="2039040"/>
-            <a:ext cx="108720" cy="108720"/>
+            <a:ext cx="108360" cy="108360"/>
           </a:xfrm>
           <a:prstGeom prst="ellipse">
             <a:avLst/>
@@ -5471,7 +5477,7 @@
         <p:spPr>
           <a:xfrm>
             <a:off x="475560" y="2039040"/>
-            <a:ext cx="108720" cy="108720"/>
+            <a:ext cx="108360" cy="108360"/>
           </a:xfrm>
           <a:prstGeom prst="ellipse">
             <a:avLst/>
@@ -5502,7 +5508,7 @@
         <p:spPr>
           <a:xfrm>
             <a:off x="658440" y="2039040"/>
-            <a:ext cx="108720" cy="108720"/>
+            <a:ext cx="108360" cy="108360"/>
           </a:xfrm>
           <a:prstGeom prst="ellipse">
             <a:avLst/>
@@ -5533,7 +5539,7 @@
         <p:spPr>
           <a:xfrm>
             <a:off x="182880" y="1993320"/>
-            <a:ext cx="5576760" cy="200160"/>
+            <a:ext cx="5576400" cy="199800"/>
           </a:xfrm>
           <a:prstGeom prst="rect">
             <a:avLst/>
@@ -5587,8 +5593,8 @@
         </p:nvSpPr>
         <p:spPr>
           <a:xfrm>
-            <a:off x="292680" y="2249280"/>
-            <a:ext cx="5439600" cy="2531880"/>
+            <a:off x="320760" y="2249280"/>
+            <a:ext cx="5439240" cy="2531520"/>
           </a:xfrm>
           <a:prstGeom prst="rect">
             <a:avLst/>
@@ -6398,7 +6404,7 @@
         <p:spPr>
           <a:xfrm>
             <a:off x="6035040" y="1974960"/>
-            <a:ext cx="2925000" cy="2879280"/>
+            <a:ext cx="2924640" cy="2878920"/>
           </a:xfrm>
           <a:prstGeom prst="rect">
             <a:avLst/>
@@ -6436,7 +6442,7 @@
         <p:spPr>
           <a:xfrm>
             <a:off x="6172200" y="2084760"/>
-            <a:ext cx="2650680" cy="593280"/>
+            <a:ext cx="2650320" cy="592920"/>
           </a:xfrm>
           <a:prstGeom prst="rect">
             <a:avLst/>
@@ -6515,7 +6521,7 @@
         <p:spPr>
           <a:xfrm>
             <a:off x="6172200" y="2743200"/>
-            <a:ext cx="2650680" cy="2010600"/>
+            <a:ext cx="2650320" cy="2010240"/>
           </a:xfrm>
           <a:prstGeom prst="rect">
             <a:avLst/>
@@ -6683,7 +6689,7 @@
         <p:spPr>
           <a:xfrm>
             <a:off x="0" y="0"/>
-            <a:ext cx="63000" cy="5142600"/>
+            <a:ext cx="62640" cy="5142240"/>
           </a:xfrm>
           <a:prstGeom prst="rect">
             <a:avLst/>
@@ -6714,7 +6720,7 @@
         <p:spPr>
           <a:xfrm>
             <a:off x="0" y="0"/>
-            <a:ext cx="9142920" cy="712080"/>
+            <a:ext cx="9142560" cy="711720"/>
           </a:xfrm>
           <a:prstGeom prst="rect">
             <a:avLst/>
@@ -6745,7 +6751,7 @@
         <p:spPr>
           <a:xfrm>
             <a:off x="182880" y="0"/>
-            <a:ext cx="7131240" cy="712080"/>
+            <a:ext cx="7130880" cy="711720"/>
           </a:xfrm>
           <a:prstGeom prst="rect">
             <a:avLst/>
@@ -6800,7 +6806,7 @@
         <p:spPr>
           <a:xfrm>
             <a:off x="7589520" y="109800"/>
-            <a:ext cx="1370520" cy="474480"/>
+            <a:ext cx="1370160" cy="474120"/>
           </a:xfrm>
           <a:prstGeom prst="rect">
             <a:avLst/>
@@ -6838,7 +6844,7 @@
         <p:spPr>
           <a:xfrm>
             <a:off x="7589520" y="109800"/>
-            <a:ext cx="1370520" cy="474480"/>
+            <a:ext cx="1370160" cy="474120"/>
           </a:xfrm>
           <a:prstGeom prst="rect">
             <a:avLst/>
@@ -6893,7 +6899,7 @@
         <p:spPr>
           <a:xfrm>
             <a:off x="182880" y="777240"/>
-            <a:ext cx="8777160" cy="346320"/>
+            <a:ext cx="8776800" cy="345960"/>
           </a:xfrm>
           <a:prstGeom prst="rect">
             <a:avLst/>
@@ -6948,7 +6954,7 @@
         <p:spPr>
           <a:xfrm>
             <a:off x="182880" y="1207080"/>
-            <a:ext cx="5036400" cy="4192200"/>
+            <a:ext cx="5036040" cy="4191840"/>
           </a:xfrm>
           <a:prstGeom prst="rect">
             <a:avLst/>
@@ -6986,7 +6992,7 @@
         <p:spPr>
           <a:xfrm>
             <a:off x="182880" y="1207080"/>
-            <a:ext cx="5028120" cy="254880"/>
+            <a:ext cx="5027760" cy="254520"/>
           </a:xfrm>
           <a:prstGeom prst="rect">
             <a:avLst/>
@@ -7017,7 +7023,7 @@
         <p:spPr>
           <a:xfrm>
             <a:off x="292680" y="1271160"/>
-            <a:ext cx="108720" cy="108720"/>
+            <a:ext cx="108360" cy="108360"/>
           </a:xfrm>
           <a:prstGeom prst="ellipse">
             <a:avLst/>
@@ -7048,7 +7054,7 @@
         <p:spPr>
           <a:xfrm>
             <a:off x="475560" y="1271160"/>
-            <a:ext cx="108720" cy="108720"/>
+            <a:ext cx="108360" cy="108360"/>
           </a:xfrm>
           <a:prstGeom prst="ellipse">
             <a:avLst/>
@@ -7079,7 +7085,7 @@
         <p:spPr>
           <a:xfrm>
             <a:off x="658440" y="1271160"/>
-            <a:ext cx="108720" cy="108720"/>
+            <a:ext cx="108360" cy="108360"/>
           </a:xfrm>
           <a:prstGeom prst="ellipse">
             <a:avLst/>
@@ -7110,7 +7116,7 @@
         <p:spPr>
           <a:xfrm>
             <a:off x="182880" y="1225440"/>
-            <a:ext cx="4936680" cy="200160"/>
+            <a:ext cx="4936320" cy="199800"/>
           </a:xfrm>
           <a:prstGeom prst="rect">
             <a:avLst/>
@@ -7165,7 +7171,7 @@
         <p:spPr>
           <a:xfrm>
             <a:off x="292680" y="1481400"/>
-            <a:ext cx="4799520" cy="3309120"/>
+            <a:ext cx="4799160" cy="3308760"/>
           </a:xfrm>
           <a:prstGeom prst="rect">
             <a:avLst/>
@@ -8144,7 +8150,7 @@
         <p:spPr>
           <a:xfrm>
             <a:off x="5394960" y="1207080"/>
-            <a:ext cx="3565080" cy="657360"/>
+            <a:ext cx="3564720" cy="657000"/>
           </a:xfrm>
           <a:prstGeom prst="rect">
             <a:avLst/>
@@ -8182,7 +8188,7 @@
         <p:spPr>
           <a:xfrm>
             <a:off x="5394960" y="1207080"/>
-            <a:ext cx="53640" cy="657360"/>
+            <a:ext cx="53280" cy="657000"/>
           </a:xfrm>
           <a:prstGeom prst="rect">
             <a:avLst/>
@@ -8213,7 +8219,7 @@
         <p:spPr>
           <a:xfrm>
             <a:off x="5541120" y="1252800"/>
-            <a:ext cx="3336480" cy="254880"/>
+            <a:ext cx="3336120" cy="254520"/>
           </a:xfrm>
           <a:prstGeom prst="rect">
             <a:avLst/>
@@ -8268,7 +8274,7 @@
         <p:spPr>
           <a:xfrm>
             <a:off x="5541120" y="1517760"/>
-            <a:ext cx="3336480" cy="254880"/>
+            <a:ext cx="3336120" cy="254520"/>
           </a:xfrm>
           <a:prstGeom prst="rect">
             <a:avLst/>
@@ -8323,7 +8329,7 @@
         <p:spPr>
           <a:xfrm>
             <a:off x="5394960" y="1938600"/>
-            <a:ext cx="3565080" cy="657360"/>
+            <a:ext cx="3564720" cy="657000"/>
           </a:xfrm>
           <a:prstGeom prst="rect">
             <a:avLst/>
@@ -8361,7 +8367,7 @@
         <p:spPr>
           <a:xfrm>
             <a:off x="5394960" y="1938600"/>
-            <a:ext cx="53640" cy="657360"/>
+            <a:ext cx="53280" cy="657000"/>
           </a:xfrm>
           <a:prstGeom prst="rect">
             <a:avLst/>
@@ -8392,7 +8398,7 @@
         <p:spPr>
           <a:xfrm>
             <a:off x="5541120" y="1984320"/>
-            <a:ext cx="3336480" cy="254880"/>
+            <a:ext cx="3336120" cy="254520"/>
           </a:xfrm>
           <a:prstGeom prst="rect">
             <a:avLst/>
@@ -8447,7 +8453,7 @@
         <p:spPr>
           <a:xfrm>
             <a:off x="5541120" y="2249280"/>
-            <a:ext cx="3336480" cy="254880"/>
+            <a:ext cx="3336120" cy="254520"/>
           </a:xfrm>
           <a:prstGeom prst="rect">
             <a:avLst/>
@@ -8502,7 +8508,7 @@
         <p:spPr>
           <a:xfrm>
             <a:off x="5394960" y="2670120"/>
-            <a:ext cx="3565080" cy="657360"/>
+            <a:ext cx="3564720" cy="657000"/>
           </a:xfrm>
           <a:prstGeom prst="rect">
             <a:avLst/>
@@ -8540,7 +8546,7 @@
         <p:spPr>
           <a:xfrm>
             <a:off x="5394960" y="2670120"/>
-            <a:ext cx="53640" cy="657360"/>
+            <a:ext cx="53280" cy="657000"/>
           </a:xfrm>
           <a:prstGeom prst="rect">
             <a:avLst/>
@@ -8571,7 +8577,7 @@
         <p:spPr>
           <a:xfrm>
             <a:off x="5541120" y="2715840"/>
-            <a:ext cx="3336480" cy="254880"/>
+            <a:ext cx="3336120" cy="254520"/>
           </a:xfrm>
           <a:prstGeom prst="rect">
             <a:avLst/>
@@ -8626,7 +8632,7 @@
         <p:spPr>
           <a:xfrm>
             <a:off x="5541120" y="2980800"/>
-            <a:ext cx="3336480" cy="254880"/>
+            <a:ext cx="3336120" cy="254520"/>
           </a:xfrm>
           <a:prstGeom prst="rect">
             <a:avLst/>
@@ -8681,7 +8687,7 @@
         <p:spPr>
           <a:xfrm>
             <a:off x="5394960" y="3401640"/>
-            <a:ext cx="3565080" cy="657360"/>
+            <a:ext cx="3564720" cy="657000"/>
           </a:xfrm>
           <a:prstGeom prst="rect">
             <a:avLst/>
@@ -8719,7 +8725,7 @@
         <p:spPr>
           <a:xfrm>
             <a:off x="5394960" y="3401640"/>
-            <a:ext cx="53640" cy="657360"/>
+            <a:ext cx="53280" cy="657000"/>
           </a:xfrm>
           <a:prstGeom prst="rect">
             <a:avLst/>
@@ -8750,7 +8756,7 @@
         <p:spPr>
           <a:xfrm>
             <a:off x="5541120" y="3447360"/>
-            <a:ext cx="3336480" cy="254880"/>
+            <a:ext cx="3336120" cy="254520"/>
           </a:xfrm>
           <a:prstGeom prst="rect">
             <a:avLst/>
@@ -8805,7 +8811,7 @@
         <p:spPr>
           <a:xfrm>
             <a:off x="5541120" y="3712320"/>
-            <a:ext cx="3336480" cy="254880"/>
+            <a:ext cx="3336120" cy="254520"/>
           </a:xfrm>
           <a:prstGeom prst="rect">
             <a:avLst/>
@@ -8860,7 +8866,7 @@
         <p:spPr>
           <a:xfrm>
             <a:off x="5394960" y="4133160"/>
-            <a:ext cx="3565080" cy="657360"/>
+            <a:ext cx="3564720" cy="657000"/>
           </a:xfrm>
           <a:prstGeom prst="rect">
             <a:avLst/>
@@ -8898,7 +8904,7 @@
         <p:spPr>
           <a:xfrm>
             <a:off x="5394960" y="4133160"/>
-            <a:ext cx="53640" cy="657360"/>
+            <a:ext cx="53280" cy="657000"/>
           </a:xfrm>
           <a:prstGeom prst="rect">
             <a:avLst/>
@@ -8929,7 +8935,7 @@
         <p:spPr>
           <a:xfrm>
             <a:off x="5541120" y="4178880"/>
-            <a:ext cx="3336480" cy="254880"/>
+            <a:ext cx="3336120" cy="254520"/>
           </a:xfrm>
           <a:prstGeom prst="rect">
             <a:avLst/>
@@ -8984,7 +8990,7 @@
         <p:spPr>
           <a:xfrm>
             <a:off x="5541120" y="4443840"/>
-            <a:ext cx="3336480" cy="254880"/>
+            <a:ext cx="3336120" cy="254520"/>
           </a:xfrm>
           <a:prstGeom prst="rect">
             <a:avLst/>
@@ -9076,7 +9082,7 @@
         <p:spPr>
           <a:xfrm>
             <a:off x="0" y="0"/>
-            <a:ext cx="63000" cy="5142600"/>
+            <a:ext cx="62640" cy="5142240"/>
           </a:xfrm>
           <a:prstGeom prst="rect">
             <a:avLst/>
@@ -9107,7 +9113,7 @@
         <p:spPr>
           <a:xfrm>
             <a:off x="0" y="0"/>
-            <a:ext cx="9142920" cy="712080"/>
+            <a:ext cx="9142560" cy="711720"/>
           </a:xfrm>
           <a:prstGeom prst="rect">
             <a:avLst/>
@@ -9138,7 +9144,7 @@
         <p:spPr>
           <a:xfrm>
             <a:off x="182880" y="0"/>
-            <a:ext cx="7131240" cy="712080"/>
+            <a:ext cx="7130880" cy="711720"/>
           </a:xfrm>
           <a:prstGeom prst="rect">
             <a:avLst/>
@@ -9193,7 +9199,7 @@
         <p:spPr>
           <a:xfrm>
             <a:off x="7589520" y="109800"/>
-            <a:ext cx="1370520" cy="474480"/>
+            <a:ext cx="1370160" cy="474120"/>
           </a:xfrm>
           <a:prstGeom prst="rect">
             <a:avLst/>
@@ -9231,7 +9237,7 @@
         <p:spPr>
           <a:xfrm>
             <a:off x="7589520" y="109800"/>
-            <a:ext cx="1370520" cy="474480"/>
+            <a:ext cx="1370160" cy="474120"/>
           </a:xfrm>
           <a:prstGeom prst="rect">
             <a:avLst/>
@@ -9374,7 +9380,7 @@
                           </a:solidFill>
                           <a:latin typeface="Calibri"/>
                         </a:rPr>
-                        <a:t>Regular Method</a:t>
+                        <a:t>Regular/Instance Method</a:t>
                       </a:r>
                       <a:endParaRPr b="0" lang="en-IN" sz="1300" spc="-1" strike="noStrike">
                         <a:latin typeface="Arial"/>
@@ -10478,7 +10484,7 @@
         <p:spPr>
           <a:xfrm>
             <a:off x="182880" y="4736520"/>
-            <a:ext cx="8777160" cy="291600"/>
+            <a:ext cx="8776800" cy="291240"/>
           </a:xfrm>
           <a:prstGeom prst="rect">
             <a:avLst/>
@@ -10509,7 +10515,7 @@
         <p:spPr>
           <a:xfrm>
             <a:off x="320040" y="4754880"/>
-            <a:ext cx="8502840" cy="254880"/>
+            <a:ext cx="8502480" cy="254520"/>
           </a:xfrm>
           <a:prstGeom prst="rect">
             <a:avLst/>
@@ -10601,7 +10607,7 @@
         <p:spPr>
           <a:xfrm>
             <a:off x="30240" y="-449640"/>
-            <a:ext cx="9142920" cy="5142600"/>
+            <a:ext cx="9142560" cy="5142240"/>
           </a:xfrm>
           <a:prstGeom prst="rect">
             <a:avLst/>
@@ -10632,7 +10638,7 @@
         <p:spPr>
           <a:xfrm>
             <a:off x="0" y="0"/>
-            <a:ext cx="63000" cy="5142600"/>
+            <a:ext cx="62640" cy="5142240"/>
           </a:xfrm>
           <a:prstGeom prst="rect">
             <a:avLst/>
@@ -10663,7 +10669,7 @@
         <p:spPr>
           <a:xfrm>
             <a:off x="914400" y="360000"/>
-            <a:ext cx="7314120" cy="364680"/>
+            <a:ext cx="7313760" cy="364320"/>
           </a:xfrm>
           <a:prstGeom prst="rect">
             <a:avLst/>
@@ -10694,7 +10700,7 @@
               </a:tabLst>
             </a:pPr>
             <a:r>
-              <a:rPr b="1" lang="en-US" sz="1300" spc="491" strike="noStrike">
+              <a:rPr b="1" lang="en-US" sz="1300" spc="488" strike="noStrike">
                 <a:solidFill>
                   <a:srgbClr val="34d399"/>
                 </a:solidFill>
@@ -10717,8 +10723,8 @@
         </p:nvSpPr>
         <p:spPr>
           <a:xfrm rot="21587400">
-            <a:off x="910800" y="780120"/>
-            <a:ext cx="7314120" cy="1004760"/>
+            <a:off x="910800" y="779760"/>
+            <a:ext cx="7313760" cy="1004400"/>
           </a:xfrm>
           <a:prstGeom prst="rect">
             <a:avLst/>
@@ -10773,7 +10779,7 @@
         <p:spPr>
           <a:xfrm>
             <a:off x="900000" y="2114640"/>
-            <a:ext cx="7314120" cy="44640"/>
+            <a:ext cx="7313760" cy="44280"/>
           </a:xfrm>
           <a:prstGeom prst="rect">
             <a:avLst/>
@@ -10804,7 +10810,7 @@
         <p:spPr>
           <a:xfrm>
             <a:off x="914400" y="2240280"/>
-            <a:ext cx="318960" cy="364680"/>
+            <a:ext cx="318600" cy="364320"/>
           </a:xfrm>
           <a:prstGeom prst="rect">
             <a:avLst/>
@@ -10859,7 +10865,7 @@
         <p:spPr>
           <a:xfrm>
             <a:off x="1298520" y="2240280"/>
-            <a:ext cx="2010600" cy="346320"/>
+            <a:ext cx="2010240" cy="345960"/>
           </a:xfrm>
           <a:prstGeom prst="rect">
             <a:avLst/>
@@ -10914,7 +10920,7 @@
         <p:spPr>
           <a:xfrm>
             <a:off x="3474720" y="2277000"/>
-            <a:ext cx="5028120" cy="346320"/>
+            <a:ext cx="5027760" cy="345960"/>
           </a:xfrm>
           <a:prstGeom prst="rect">
             <a:avLst/>
@@ -10969,7 +10975,7 @@
         <p:spPr>
           <a:xfrm>
             <a:off x="914400" y="3108960"/>
-            <a:ext cx="318960" cy="364680"/>
+            <a:ext cx="318600" cy="364320"/>
           </a:xfrm>
           <a:prstGeom prst="rect">
             <a:avLst/>
@@ -11024,7 +11030,7 @@
         <p:spPr>
           <a:xfrm>
             <a:off x="1298520" y="3108960"/>
-            <a:ext cx="2010600" cy="346320"/>
+            <a:ext cx="2010240" cy="345960"/>
           </a:xfrm>
           <a:prstGeom prst="rect">
             <a:avLst/>
@@ -11079,7 +11085,7 @@
         <p:spPr>
           <a:xfrm>
             <a:off x="3474720" y="3145680"/>
-            <a:ext cx="5028120" cy="346320"/>
+            <a:ext cx="5027760" cy="345960"/>
           </a:xfrm>
           <a:prstGeom prst="rect">
             <a:avLst/>
@@ -11134,7 +11140,7 @@
         <p:spPr>
           <a:xfrm>
             <a:off x="914400" y="3977640"/>
-            <a:ext cx="318960" cy="364680"/>
+            <a:ext cx="318600" cy="364320"/>
           </a:xfrm>
           <a:prstGeom prst="rect">
             <a:avLst/>
@@ -11189,7 +11195,7 @@
         <p:spPr>
           <a:xfrm>
             <a:off x="1298520" y="3977640"/>
-            <a:ext cx="2010600" cy="346320"/>
+            <a:ext cx="2010240" cy="345960"/>
           </a:xfrm>
           <a:prstGeom prst="rect">
             <a:avLst/>
@@ -11244,7 +11250,7 @@
         <p:spPr>
           <a:xfrm>
             <a:off x="3474720" y="4014360"/>
-            <a:ext cx="5028120" cy="346320"/>
+            <a:ext cx="5027760" cy="345960"/>
           </a:xfrm>
           <a:prstGeom prst="rect">
             <a:avLst/>
@@ -11299,7 +11305,7 @@
         <p:spPr>
           <a:xfrm>
             <a:off x="914400" y="4709160"/>
-            <a:ext cx="7771320" cy="273240"/>
+            <a:ext cx="7770960" cy="272880"/>
           </a:xfrm>
           <a:prstGeom prst="rect">
             <a:avLst/>
@@ -11391,7 +11397,7 @@
         <p:spPr>
           <a:xfrm>
             <a:off x="0" y="0"/>
-            <a:ext cx="63000" cy="5142600"/>
+            <a:ext cx="62640" cy="5142240"/>
           </a:xfrm>
           <a:prstGeom prst="rect">
             <a:avLst/>
@@ -11422,7 +11428,7 @@
         <p:spPr>
           <a:xfrm>
             <a:off x="0" y="0"/>
-            <a:ext cx="9142920" cy="712080"/>
+            <a:ext cx="9142560" cy="711720"/>
           </a:xfrm>
           <a:prstGeom prst="rect">
             <a:avLst/>
@@ -11453,7 +11459,7 @@
         <p:spPr>
           <a:xfrm>
             <a:off x="182880" y="0"/>
-            <a:ext cx="7131240" cy="712080"/>
+            <a:ext cx="7130880" cy="711720"/>
           </a:xfrm>
           <a:prstGeom prst="rect">
             <a:avLst/>
@@ -11508,7 +11514,7 @@
         <p:spPr>
           <a:xfrm>
             <a:off x="7589520" y="109800"/>
-            <a:ext cx="1370520" cy="474480"/>
+            <a:ext cx="1370160" cy="474120"/>
           </a:xfrm>
           <a:prstGeom prst="rect">
             <a:avLst/>
@@ -11546,7 +11552,7 @@
         <p:spPr>
           <a:xfrm>
             <a:off x="7589520" y="109800"/>
-            <a:ext cx="1370520" cy="474480"/>
+            <a:ext cx="1370160" cy="474120"/>
           </a:xfrm>
           <a:prstGeom prst="rect">
             <a:avLst/>
@@ -11601,7 +11607,7 @@
         <p:spPr>
           <a:xfrm>
             <a:off x="182880" y="804600"/>
-            <a:ext cx="8777160" cy="1279080"/>
+            <a:ext cx="8776800" cy="1278720"/>
           </a:xfrm>
           <a:prstGeom prst="rect">
             <a:avLst/>
@@ -11639,7 +11645,7 @@
         <p:spPr>
           <a:xfrm>
             <a:off x="182880" y="804600"/>
-            <a:ext cx="53640" cy="1279080"/>
+            <a:ext cx="53280" cy="1278720"/>
           </a:xfrm>
           <a:prstGeom prst="rect">
             <a:avLst/>
@@ -11670,7 +11676,7 @@
         <p:spPr>
           <a:xfrm>
             <a:off x="365760" y="896040"/>
-            <a:ext cx="2742120" cy="273240"/>
+            <a:ext cx="2741760" cy="272880"/>
           </a:xfrm>
           <a:prstGeom prst="rect">
             <a:avLst/>
@@ -11701,7 +11707,7 @@
               </a:tabLst>
             </a:pPr>
             <a:r>
-              <a:rPr b="1" lang="en-US" sz="1000" spc="194" strike="noStrike">
+              <a:rPr b="1" lang="en-US" sz="1000" spc="191" strike="noStrike">
                 <a:solidFill>
                   <a:srgbClr val="38bdf8"/>
                 </a:solidFill>
@@ -11725,7 +11731,7 @@
         <p:spPr>
           <a:xfrm>
             <a:off x="365760" y="1188720"/>
-            <a:ext cx="8319960" cy="547560"/>
+            <a:ext cx="8319600" cy="547200"/>
           </a:xfrm>
           <a:prstGeom prst="rect">
             <a:avLst/>
@@ -11780,7 +11786,7 @@
         <p:spPr>
           <a:xfrm>
             <a:off x="182880" y="2212920"/>
-            <a:ext cx="5119560" cy="2604960"/>
+            <a:ext cx="5119200" cy="2604600"/>
           </a:xfrm>
           <a:prstGeom prst="rect">
             <a:avLst/>
@@ -11818,7 +11824,7 @@
         <p:spPr>
           <a:xfrm>
             <a:off x="182880" y="2212920"/>
-            <a:ext cx="5119560" cy="254880"/>
+            <a:ext cx="5119200" cy="254520"/>
           </a:xfrm>
           <a:prstGeom prst="rect">
             <a:avLst/>
@@ -11849,7 +11855,7 @@
         <p:spPr>
           <a:xfrm>
             <a:off x="292680" y="2277000"/>
-            <a:ext cx="108720" cy="108720"/>
+            <a:ext cx="108360" cy="108360"/>
           </a:xfrm>
           <a:prstGeom prst="ellipse">
             <a:avLst/>
@@ -11880,7 +11886,7 @@
         <p:spPr>
           <a:xfrm>
             <a:off x="475560" y="2277000"/>
-            <a:ext cx="108720" cy="108720"/>
+            <a:ext cx="108360" cy="108360"/>
           </a:xfrm>
           <a:prstGeom prst="ellipse">
             <a:avLst/>
@@ -11911,7 +11917,7 @@
         <p:spPr>
           <a:xfrm>
             <a:off x="658440" y="2277000"/>
-            <a:ext cx="108720" cy="108720"/>
+            <a:ext cx="108360" cy="108360"/>
           </a:xfrm>
           <a:prstGeom prst="ellipse">
             <a:avLst/>
@@ -11942,7 +11948,7 @@
         <p:spPr>
           <a:xfrm>
             <a:off x="182880" y="2231280"/>
-            <a:ext cx="5028120" cy="200160"/>
+            <a:ext cx="5027760" cy="199800"/>
           </a:xfrm>
           <a:prstGeom prst="rect">
             <a:avLst/>
@@ -11997,7 +12003,7 @@
         <p:spPr>
           <a:xfrm>
             <a:off x="292680" y="2487240"/>
-            <a:ext cx="4890960" cy="2257560"/>
+            <a:ext cx="4890600" cy="2257200"/>
           </a:xfrm>
           <a:prstGeom prst="rect">
             <a:avLst/>
@@ -12423,7 +12429,7 @@
         <p:spPr>
           <a:xfrm>
             <a:off x="5486400" y="2212920"/>
-            <a:ext cx="3473640" cy="2604960"/>
+            <a:ext cx="3473280" cy="2604600"/>
           </a:xfrm>
           <a:prstGeom prst="rect">
             <a:avLst/>
@@ -12461,7 +12467,7 @@
         <p:spPr>
           <a:xfrm>
             <a:off x="5623560" y="2331720"/>
-            <a:ext cx="3199320" cy="364680"/>
+            <a:ext cx="3198960" cy="364320"/>
           </a:xfrm>
           <a:prstGeom prst="rect">
             <a:avLst/>
@@ -12516,7 +12522,7 @@
         <p:spPr>
           <a:xfrm>
             <a:off x="5623560" y="2788920"/>
-            <a:ext cx="3199320" cy="1919160"/>
+            <a:ext cx="3198960" cy="1918800"/>
           </a:xfrm>
           <a:prstGeom prst="rect">
             <a:avLst/>
@@ -12709,7 +12715,7 @@
         <p:spPr>
           <a:xfrm>
             <a:off x="0" y="0"/>
-            <a:ext cx="9142920" cy="5142600"/>
+            <a:ext cx="9142560" cy="5142240"/>
           </a:xfrm>
           <a:prstGeom prst="rect">
             <a:avLst/>
@@ -12742,7 +12748,7 @@
         <p:spPr>
           <a:xfrm>
             <a:off x="274320" y="457200"/>
-            <a:ext cx="2284920" cy="2742120"/>
+            <a:ext cx="2284560" cy="2741760"/>
           </a:xfrm>
           <a:prstGeom prst="rect">
             <a:avLst/>
@@ -12799,7 +12805,7 @@
         <p:spPr>
           <a:xfrm>
             <a:off x="1005840" y="1645920"/>
-            <a:ext cx="7131240" cy="53640"/>
+            <a:ext cx="7130880" cy="53280"/>
           </a:xfrm>
           <a:prstGeom prst="rect">
             <a:avLst/>
@@ -12830,7 +12836,7 @@
         <p:spPr>
           <a:xfrm>
             <a:off x="1005840" y="1783080"/>
-            <a:ext cx="7771320" cy="1370520"/>
+            <a:ext cx="7770960" cy="1370160"/>
           </a:xfrm>
           <a:prstGeom prst="rect">
             <a:avLst/>
@@ -12885,7 +12891,7 @@
         <p:spPr>
           <a:xfrm>
             <a:off x="1005840" y="3200400"/>
-            <a:ext cx="7771320" cy="821880"/>
+            <a:ext cx="7770960" cy="821520"/>
           </a:xfrm>
           <a:prstGeom prst="rect">
             <a:avLst/>
@@ -12977,7 +12983,7 @@
         <p:spPr>
           <a:xfrm>
             <a:off x="0" y="0"/>
-            <a:ext cx="63000" cy="5142600"/>
+            <a:ext cx="62640" cy="5142240"/>
           </a:xfrm>
           <a:prstGeom prst="rect">
             <a:avLst/>
@@ -13008,7 +13014,7 @@
         <p:spPr>
           <a:xfrm>
             <a:off x="0" y="0"/>
-            <a:ext cx="9142920" cy="712080"/>
+            <a:ext cx="9142560" cy="711720"/>
           </a:xfrm>
           <a:prstGeom prst="rect">
             <a:avLst/>
@@ -13039,7 +13045,7 @@
         <p:spPr>
           <a:xfrm>
             <a:off x="182880" y="0"/>
-            <a:ext cx="7131240" cy="712080"/>
+            <a:ext cx="7130880" cy="711720"/>
           </a:xfrm>
           <a:prstGeom prst="rect">
             <a:avLst/>
@@ -13094,7 +13100,7 @@
         <p:spPr>
           <a:xfrm>
             <a:off x="7589520" y="109800"/>
-            <a:ext cx="1370520" cy="474480"/>
+            <a:ext cx="1370160" cy="474120"/>
           </a:xfrm>
           <a:prstGeom prst="rect">
             <a:avLst/>
@@ -13132,7 +13138,7 @@
         <p:spPr>
           <a:xfrm>
             <a:off x="7589520" y="109800"/>
-            <a:ext cx="1370520" cy="474480"/>
+            <a:ext cx="1370160" cy="474120"/>
           </a:xfrm>
           <a:prstGeom prst="rect">
             <a:avLst/>
@@ -13187,7 +13193,7 @@
         <p:spPr>
           <a:xfrm>
             <a:off x="182880" y="804600"/>
-            <a:ext cx="5216400" cy="4594680"/>
+            <a:ext cx="5216040" cy="4594320"/>
           </a:xfrm>
           <a:prstGeom prst="rect">
             <a:avLst/>
@@ -13225,7 +13231,7 @@
         <p:spPr>
           <a:xfrm>
             <a:off x="182880" y="804600"/>
-            <a:ext cx="5211000" cy="254880"/>
+            <a:ext cx="5210640" cy="254520"/>
           </a:xfrm>
           <a:prstGeom prst="rect">
             <a:avLst/>
@@ -13256,7 +13262,7 @@
         <p:spPr>
           <a:xfrm>
             <a:off x="292680" y="868680"/>
-            <a:ext cx="108720" cy="108720"/>
+            <a:ext cx="108360" cy="108360"/>
           </a:xfrm>
           <a:prstGeom prst="ellipse">
             <a:avLst/>
@@ -13287,7 +13293,7 @@
         <p:spPr>
           <a:xfrm>
             <a:off x="475560" y="868680"/>
-            <a:ext cx="108720" cy="108720"/>
+            <a:ext cx="108360" cy="108360"/>
           </a:xfrm>
           <a:prstGeom prst="ellipse">
             <a:avLst/>
@@ -13318,7 +13324,7 @@
         <p:spPr>
           <a:xfrm>
             <a:off x="658440" y="868680"/>
-            <a:ext cx="108720" cy="108720"/>
+            <a:ext cx="108360" cy="108360"/>
           </a:xfrm>
           <a:prstGeom prst="ellipse">
             <a:avLst/>
@@ -13349,7 +13355,7 @@
         <p:spPr>
           <a:xfrm>
             <a:off x="182880" y="822960"/>
-            <a:ext cx="5119560" cy="200160"/>
+            <a:ext cx="5119200" cy="199800"/>
           </a:xfrm>
           <a:prstGeom prst="rect">
             <a:avLst/>
@@ -13404,7 +13410,7 @@
         <p:spPr>
           <a:xfrm>
             <a:off x="292680" y="1078920"/>
-            <a:ext cx="4982400" cy="3720600"/>
+            <a:ext cx="4982040" cy="3720240"/>
           </a:xfrm>
           <a:prstGeom prst="rect">
             <a:avLst/>
@@ -14406,7 +14412,7 @@
         <p:spPr>
           <a:xfrm>
             <a:off x="5577840" y="804600"/>
-            <a:ext cx="3421440" cy="4338360"/>
+            <a:ext cx="3421080" cy="4338000"/>
           </a:xfrm>
           <a:prstGeom prst="rect">
             <a:avLst/>
@@ -14444,7 +14450,7 @@
         <p:spPr>
           <a:xfrm>
             <a:off x="5715000" y="896040"/>
-            <a:ext cx="3107880" cy="346320"/>
+            <a:ext cx="3107520" cy="345960"/>
           </a:xfrm>
           <a:prstGeom prst="rect">
             <a:avLst/>
@@ -14499,7 +14505,7 @@
         <p:spPr>
           <a:xfrm>
             <a:off x="5715000" y="1325880"/>
-            <a:ext cx="3107880" cy="254880"/>
+            <a:ext cx="3107520" cy="254520"/>
           </a:xfrm>
           <a:prstGeom prst="rect">
             <a:avLst/>
@@ -14554,7 +14560,7 @@
         <p:spPr>
           <a:xfrm>
             <a:off x="5715000" y="1581840"/>
-            <a:ext cx="3107880" cy="456120"/>
+            <a:ext cx="3107520" cy="455760"/>
           </a:xfrm>
           <a:prstGeom prst="rect">
             <a:avLst/>
@@ -14609,7 +14615,7 @@
         <p:spPr>
           <a:xfrm>
             <a:off x="5715000" y="2103120"/>
-            <a:ext cx="3107880" cy="254880"/>
+            <a:ext cx="3107520" cy="254520"/>
           </a:xfrm>
           <a:prstGeom prst="rect">
             <a:avLst/>
@@ -14664,7 +14670,7 @@
         <p:spPr>
           <a:xfrm>
             <a:off x="5715000" y="2359080"/>
-            <a:ext cx="3107880" cy="456120"/>
+            <a:ext cx="3107520" cy="455760"/>
           </a:xfrm>
           <a:prstGeom prst="rect">
             <a:avLst/>
@@ -14719,7 +14725,7 @@
         <p:spPr>
           <a:xfrm>
             <a:off x="5715000" y="2880360"/>
-            <a:ext cx="3107880" cy="254880"/>
+            <a:ext cx="3107520" cy="254520"/>
           </a:xfrm>
           <a:prstGeom prst="rect">
             <a:avLst/>
@@ -14774,7 +14780,7 @@
         <p:spPr>
           <a:xfrm>
             <a:off x="5715000" y="3136320"/>
-            <a:ext cx="3107880" cy="456120"/>
+            <a:ext cx="3107520" cy="455760"/>
           </a:xfrm>
           <a:prstGeom prst="rect">
             <a:avLst/>
@@ -14829,7 +14835,7 @@
         <p:spPr>
           <a:xfrm>
             <a:off x="5715000" y="3657600"/>
-            <a:ext cx="3107880" cy="254880"/>
+            <a:ext cx="3107520" cy="254520"/>
           </a:xfrm>
           <a:prstGeom prst="rect">
             <a:avLst/>
@@ -14884,7 +14890,7 @@
         <p:spPr>
           <a:xfrm>
             <a:off x="5715000" y="3913560"/>
-            <a:ext cx="3107880" cy="456120"/>
+            <a:ext cx="3107520" cy="455760"/>
           </a:xfrm>
           <a:prstGeom prst="rect">
             <a:avLst/>
@@ -14939,7 +14945,7 @@
         <p:spPr>
           <a:xfrm>
             <a:off x="5715000" y="4434840"/>
-            <a:ext cx="3107880" cy="254880"/>
+            <a:ext cx="3107520" cy="254520"/>
           </a:xfrm>
           <a:prstGeom prst="rect">
             <a:avLst/>
@@ -14994,7 +15000,7 @@
         <p:spPr>
           <a:xfrm>
             <a:off x="5715000" y="4690800"/>
-            <a:ext cx="3107880" cy="456120"/>
+            <a:ext cx="3107520" cy="455760"/>
           </a:xfrm>
           <a:prstGeom prst="rect">
             <a:avLst/>
@@ -15086,7 +15092,7 @@
         <p:spPr>
           <a:xfrm>
             <a:off x="0" y="0"/>
-            <a:ext cx="63000" cy="5142600"/>
+            <a:ext cx="62640" cy="5142240"/>
           </a:xfrm>
           <a:prstGeom prst="rect">
             <a:avLst/>
@@ -15117,7 +15123,7 @@
         <p:spPr>
           <a:xfrm>
             <a:off x="0" y="0"/>
-            <a:ext cx="9142920" cy="712080"/>
+            <a:ext cx="9142560" cy="711720"/>
           </a:xfrm>
           <a:prstGeom prst="rect">
             <a:avLst/>
@@ -15148,7 +15154,7 @@
         <p:spPr>
           <a:xfrm>
             <a:off x="182880" y="0"/>
-            <a:ext cx="7131240" cy="712080"/>
+            <a:ext cx="7130880" cy="711720"/>
           </a:xfrm>
           <a:prstGeom prst="rect">
             <a:avLst/>
@@ -15203,7 +15209,7 @@
         <p:spPr>
           <a:xfrm>
             <a:off x="7589520" y="109800"/>
-            <a:ext cx="1370520" cy="474480"/>
+            <a:ext cx="1370160" cy="474120"/>
           </a:xfrm>
           <a:prstGeom prst="rect">
             <a:avLst/>
@@ -15241,7 +15247,7 @@
         <p:spPr>
           <a:xfrm>
             <a:off x="7589520" y="109800"/>
-            <a:ext cx="1370520" cy="474480"/>
+            <a:ext cx="1370160" cy="474120"/>
           </a:xfrm>
           <a:prstGeom prst="rect">
             <a:avLst/>
@@ -15296,7 +15302,7 @@
         <p:spPr>
           <a:xfrm>
             <a:off x="182880" y="804600"/>
-            <a:ext cx="5302440" cy="4068000"/>
+            <a:ext cx="5302080" cy="4067640"/>
           </a:xfrm>
           <a:prstGeom prst="rect">
             <a:avLst/>
@@ -15334,7 +15340,7 @@
         <p:spPr>
           <a:xfrm>
             <a:off x="182880" y="804600"/>
-            <a:ext cx="5302440" cy="254880"/>
+            <a:ext cx="5302080" cy="254520"/>
           </a:xfrm>
           <a:prstGeom prst="rect">
             <a:avLst/>
@@ -15365,7 +15371,7 @@
         <p:spPr>
           <a:xfrm>
             <a:off x="292680" y="868680"/>
-            <a:ext cx="108720" cy="108720"/>
+            <a:ext cx="108360" cy="108360"/>
           </a:xfrm>
           <a:prstGeom prst="ellipse">
             <a:avLst/>
@@ -15396,7 +15402,7 @@
         <p:spPr>
           <a:xfrm>
             <a:off x="475560" y="868680"/>
-            <a:ext cx="108720" cy="108720"/>
+            <a:ext cx="108360" cy="108360"/>
           </a:xfrm>
           <a:prstGeom prst="ellipse">
             <a:avLst/>
@@ -15427,7 +15433,7 @@
         <p:spPr>
           <a:xfrm>
             <a:off x="658440" y="868680"/>
-            <a:ext cx="108720" cy="108720"/>
+            <a:ext cx="108360" cy="108360"/>
           </a:xfrm>
           <a:prstGeom prst="ellipse">
             <a:avLst/>
@@ -15458,7 +15464,7 @@
         <p:spPr>
           <a:xfrm>
             <a:off x="182880" y="822960"/>
-            <a:ext cx="5211000" cy="200160"/>
+            <a:ext cx="5210640" cy="199800"/>
           </a:xfrm>
           <a:prstGeom prst="rect">
             <a:avLst/>
@@ -15513,7 +15519,7 @@
         <p:spPr>
           <a:xfrm>
             <a:off x="292680" y="1078920"/>
-            <a:ext cx="5073840" cy="3720600"/>
+            <a:ext cx="5073480" cy="3720240"/>
           </a:xfrm>
           <a:prstGeom prst="rect">
             <a:avLst/>
@@ -16340,7 +16346,7 @@
         <p:spPr>
           <a:xfrm>
             <a:off x="5669280" y="804600"/>
-            <a:ext cx="3290760" cy="4068000"/>
+            <a:ext cx="3290400" cy="4067640"/>
           </a:xfrm>
           <a:prstGeom prst="rect">
             <a:avLst/>
@@ -16378,7 +16384,7 @@
         <p:spPr>
           <a:xfrm>
             <a:off x="5806440" y="896040"/>
-            <a:ext cx="3016440" cy="364680"/>
+            <a:ext cx="3016080" cy="364320"/>
           </a:xfrm>
           <a:prstGeom prst="rect">
             <a:avLst/>
@@ -16433,7 +16439,7 @@
         <p:spPr>
           <a:xfrm>
             <a:off x="5806440" y="1371600"/>
-            <a:ext cx="3016440" cy="254880"/>
+            <a:ext cx="3016080" cy="254520"/>
           </a:xfrm>
           <a:prstGeom prst="rect">
             <a:avLst/>
@@ -16488,7 +16494,7 @@
         <p:spPr>
           <a:xfrm>
             <a:off x="5806440" y="1627560"/>
-            <a:ext cx="3016440" cy="593280"/>
+            <a:ext cx="3016080" cy="592920"/>
           </a:xfrm>
           <a:prstGeom prst="rect">
             <a:avLst/>
@@ -16543,7 +16549,7 @@
         <p:spPr>
           <a:xfrm>
             <a:off x="5806440" y="2331720"/>
-            <a:ext cx="3016440" cy="254880"/>
+            <a:ext cx="3016080" cy="254520"/>
           </a:xfrm>
           <a:prstGeom prst="rect">
             <a:avLst/>
@@ -16598,7 +16604,7 @@
         <p:spPr>
           <a:xfrm>
             <a:off x="5806440" y="2587680"/>
-            <a:ext cx="3016440" cy="593280"/>
+            <a:ext cx="3016080" cy="592920"/>
           </a:xfrm>
           <a:prstGeom prst="rect">
             <a:avLst/>
@@ -16653,7 +16659,7 @@
         <p:spPr>
           <a:xfrm>
             <a:off x="5806440" y="3291840"/>
-            <a:ext cx="3016440" cy="254880"/>
+            <a:ext cx="3016080" cy="254520"/>
           </a:xfrm>
           <a:prstGeom prst="rect">
             <a:avLst/>
@@ -16708,7 +16714,7 @@
         <p:spPr>
           <a:xfrm>
             <a:off x="5806440" y="3547800"/>
-            <a:ext cx="3016440" cy="593280"/>
+            <a:ext cx="3016080" cy="592920"/>
           </a:xfrm>
           <a:prstGeom prst="rect">
             <a:avLst/>
@@ -16763,7 +16769,7 @@
         <p:spPr>
           <a:xfrm>
             <a:off x="5806440" y="4251960"/>
-            <a:ext cx="3016440" cy="254880"/>
+            <a:ext cx="3016080" cy="254520"/>
           </a:xfrm>
           <a:prstGeom prst="rect">
             <a:avLst/>
@@ -16818,7 +16824,7 @@
         <p:spPr>
           <a:xfrm>
             <a:off x="5806440" y="4507920"/>
-            <a:ext cx="3016440" cy="593280"/>
+            <a:ext cx="3016080" cy="592920"/>
           </a:xfrm>
           <a:prstGeom prst="rect">
             <a:avLst/>
@@ -16910,7 +16916,7 @@
         <p:spPr>
           <a:xfrm>
             <a:off x="0" y="0"/>
-            <a:ext cx="9142920" cy="5142600"/>
+            <a:ext cx="9142560" cy="5142240"/>
           </a:xfrm>
           <a:prstGeom prst="rect">
             <a:avLst/>
@@ -16943,7 +16949,7 @@
         <p:spPr>
           <a:xfrm>
             <a:off x="274320" y="457200"/>
-            <a:ext cx="2284920" cy="2742120"/>
+            <a:ext cx="2284560" cy="2741760"/>
           </a:xfrm>
           <a:prstGeom prst="rect">
             <a:avLst/>
@@ -17000,7 +17006,7 @@
         <p:spPr>
           <a:xfrm>
             <a:off x="1005840" y="1645920"/>
-            <a:ext cx="7131240" cy="53640"/>
+            <a:ext cx="7130880" cy="53280"/>
           </a:xfrm>
           <a:prstGeom prst="rect">
             <a:avLst/>
@@ -17031,7 +17037,7 @@
         <p:spPr>
           <a:xfrm>
             <a:off x="1005840" y="1783080"/>
-            <a:ext cx="7771320" cy="1370520"/>
+            <a:ext cx="7770960" cy="1370160"/>
           </a:xfrm>
           <a:prstGeom prst="rect">
             <a:avLst/>
@@ -17086,7 +17092,7 @@
         <p:spPr>
           <a:xfrm>
             <a:off x="1005840" y="3200400"/>
-            <a:ext cx="7771320" cy="821880"/>
+            <a:ext cx="7770960" cy="821520"/>
           </a:xfrm>
           <a:prstGeom prst="rect">
             <a:avLst/>
@@ -17178,7 +17184,7 @@
         <p:spPr>
           <a:xfrm>
             <a:off x="0" y="0"/>
-            <a:ext cx="63000" cy="5142600"/>
+            <a:ext cx="62640" cy="5142240"/>
           </a:xfrm>
           <a:prstGeom prst="rect">
             <a:avLst/>
@@ -17209,7 +17215,7 @@
         <p:spPr>
           <a:xfrm>
             <a:off x="0" y="0"/>
-            <a:ext cx="9142920" cy="712080"/>
+            <a:ext cx="9142560" cy="711720"/>
           </a:xfrm>
           <a:prstGeom prst="rect">
             <a:avLst/>
@@ -17240,7 +17246,7 @@
         <p:spPr>
           <a:xfrm>
             <a:off x="182880" y="0"/>
-            <a:ext cx="7131240" cy="712080"/>
+            <a:ext cx="7130880" cy="711720"/>
           </a:xfrm>
           <a:prstGeom prst="rect">
             <a:avLst/>
@@ -17295,7 +17301,7 @@
         <p:spPr>
           <a:xfrm>
             <a:off x="7589520" y="109800"/>
-            <a:ext cx="1370520" cy="474480"/>
+            <a:ext cx="1370160" cy="474120"/>
           </a:xfrm>
           <a:prstGeom prst="rect">
             <a:avLst/>
@@ -17333,7 +17339,7 @@
         <p:spPr>
           <a:xfrm>
             <a:off x="7589520" y="109800"/>
-            <a:ext cx="1370520" cy="474480"/>
+            <a:ext cx="1370160" cy="474120"/>
           </a:xfrm>
           <a:prstGeom prst="rect">
             <a:avLst/>
@@ -17388,7 +17394,7 @@
         <p:spPr>
           <a:xfrm>
             <a:off x="182880" y="804600"/>
-            <a:ext cx="4205160" cy="4022280"/>
+            <a:ext cx="4204800" cy="4021920"/>
           </a:xfrm>
           <a:prstGeom prst="rect">
             <a:avLst/>
@@ -17426,7 +17432,7 @@
         <p:spPr>
           <a:xfrm>
             <a:off x="182880" y="804600"/>
-            <a:ext cx="4205160" cy="53640"/>
+            <a:ext cx="4204800" cy="53280"/>
           </a:xfrm>
           <a:prstGeom prst="rect">
             <a:avLst/>
@@ -17457,7 +17463,7 @@
         <p:spPr>
           <a:xfrm>
             <a:off x="320040" y="896040"/>
-            <a:ext cx="3930840" cy="273240"/>
+            <a:ext cx="3930480" cy="272880"/>
           </a:xfrm>
           <a:prstGeom prst="rect">
             <a:avLst/>
@@ -17488,7 +17494,7 @@
               </a:tabLst>
             </a:pPr>
             <a:r>
-              <a:rPr b="1" lang="en-US" sz="1100" spc="194" strike="noStrike">
+              <a:rPr b="1" lang="en-US" sz="1100" spc="191" strike="noStrike">
                 <a:solidFill>
                   <a:srgbClr val="f87171"/>
                 </a:solidFill>
@@ -17512,7 +17518,7 @@
         <p:spPr>
           <a:xfrm>
             <a:off x="320040" y="1207080"/>
-            <a:ext cx="3930840" cy="547560"/>
+            <a:ext cx="3930480" cy="547200"/>
           </a:xfrm>
           <a:prstGeom prst="rect">
             <a:avLst/>
@@ -17567,7 +17573,7 @@
         <p:spPr>
           <a:xfrm>
             <a:off x="320040" y="1828800"/>
-            <a:ext cx="3930840" cy="2604960"/>
+            <a:ext cx="3930480" cy="2604600"/>
           </a:xfrm>
           <a:prstGeom prst="rect">
             <a:avLst/>
@@ -17598,7 +17604,7 @@
         <p:spPr>
           <a:xfrm>
             <a:off x="429840" y="1883520"/>
-            <a:ext cx="3747960" cy="2495160"/>
+            <a:ext cx="3747600" cy="2494800"/>
           </a:xfrm>
           <a:prstGeom prst="rect">
             <a:avLst/>
@@ -17881,7 +17887,7 @@
         <p:spPr>
           <a:xfrm>
             <a:off x="320040" y="1828800"/>
-            <a:ext cx="3930840" cy="227520"/>
+            <a:ext cx="3930480" cy="227160"/>
           </a:xfrm>
           <a:prstGeom prst="rect">
             <a:avLst/>
@@ -17912,7 +17918,7 @@
         <p:spPr>
           <a:xfrm>
             <a:off x="429840" y="1874520"/>
-            <a:ext cx="99360" cy="99360"/>
+            <a:ext cx="99000" cy="99000"/>
           </a:xfrm>
           <a:prstGeom prst="ellipse">
             <a:avLst/>
@@ -17943,7 +17949,7 @@
         <p:spPr>
           <a:xfrm>
             <a:off x="612720" y="1874520"/>
-            <a:ext cx="99360" cy="99360"/>
+            <a:ext cx="99000" cy="99000"/>
           </a:xfrm>
           <a:prstGeom prst="ellipse">
             <a:avLst/>
@@ -17974,7 +17980,7 @@
         <p:spPr>
           <a:xfrm>
             <a:off x="795600" y="1874520"/>
-            <a:ext cx="99360" cy="99360"/>
+            <a:ext cx="99000" cy="99000"/>
           </a:xfrm>
           <a:prstGeom prst="ellipse">
             <a:avLst/>
@@ -18005,7 +18011,7 @@
         <p:spPr>
           <a:xfrm>
             <a:off x="4572000" y="804600"/>
-            <a:ext cx="4388040" cy="4022280"/>
+            <a:ext cx="4387680" cy="4021920"/>
           </a:xfrm>
           <a:prstGeom prst="rect">
             <a:avLst/>
@@ -18043,7 +18049,7 @@
         <p:spPr>
           <a:xfrm>
             <a:off x="4572000" y="804600"/>
-            <a:ext cx="4388040" cy="53640"/>
+            <a:ext cx="4387680" cy="53280"/>
           </a:xfrm>
           <a:prstGeom prst="rect">
             <a:avLst/>
@@ -18074,7 +18080,7 @@
         <p:spPr>
           <a:xfrm>
             <a:off x="4709160" y="896040"/>
-            <a:ext cx="4113720" cy="273240"/>
+            <a:ext cx="4113360" cy="272880"/>
           </a:xfrm>
           <a:prstGeom prst="rect">
             <a:avLst/>
@@ -18105,7 +18111,7 @@
               </a:tabLst>
             </a:pPr>
             <a:r>
-              <a:rPr b="1" lang="en-US" sz="1100" spc="92" strike="noStrike">
+              <a:rPr b="1" lang="en-US" sz="1100" spc="89" strike="noStrike">
                 <a:solidFill>
                   <a:srgbClr val="34d399"/>
                 </a:solidFill>
@@ -18129,7 +18135,7 @@
         <p:spPr>
           <a:xfrm>
             <a:off x="4709160" y="1207080"/>
-            <a:ext cx="4113720" cy="547560"/>
+            <a:ext cx="4113360" cy="547200"/>
           </a:xfrm>
           <a:prstGeom prst="rect">
             <a:avLst/>
@@ -18184,7 +18190,7 @@
         <p:spPr>
           <a:xfrm>
             <a:off x="4709160" y="1828800"/>
-            <a:ext cx="4113720" cy="2604960"/>
+            <a:ext cx="4113360" cy="2604600"/>
           </a:xfrm>
           <a:prstGeom prst="rect">
             <a:avLst/>
@@ -18215,7 +18221,7 @@
         <p:spPr>
           <a:xfrm>
             <a:off x="4709160" y="1828800"/>
-            <a:ext cx="4113720" cy="227520"/>
+            <a:ext cx="4113360" cy="227160"/>
           </a:xfrm>
           <a:prstGeom prst="rect">
             <a:avLst/>
@@ -18246,7 +18252,7 @@
         <p:spPr>
           <a:xfrm>
             <a:off x="4818960" y="1883520"/>
-            <a:ext cx="99360" cy="99360"/>
+            <a:ext cx="99000" cy="99000"/>
           </a:xfrm>
           <a:prstGeom prst="ellipse">
             <a:avLst/>
@@ -18277,7 +18283,7 @@
         <p:spPr>
           <a:xfrm>
             <a:off x="5001840" y="1883520"/>
-            <a:ext cx="99360" cy="99360"/>
+            <a:ext cx="99000" cy="99000"/>
           </a:xfrm>
           <a:prstGeom prst="ellipse">
             <a:avLst/>
@@ -18308,7 +18314,7 @@
         <p:spPr>
           <a:xfrm>
             <a:off x="5184720" y="1883520"/>
-            <a:ext cx="99360" cy="99360"/>
+            <a:ext cx="99000" cy="99000"/>
           </a:xfrm>
           <a:prstGeom prst="ellipse">
             <a:avLst/>
@@ -18339,7 +18345,7 @@
         <p:spPr>
           <a:xfrm>
             <a:off x="4818960" y="2084760"/>
-            <a:ext cx="3930840" cy="2303280"/>
+            <a:ext cx="3930480" cy="2302920"/>
           </a:xfrm>
           <a:prstGeom prst="rect">
             <a:avLst/>
@@ -18835,7 +18841,7 @@
         <p:spPr>
           <a:xfrm>
             <a:off x="0" y="0"/>
-            <a:ext cx="63000" cy="5142600"/>
+            <a:ext cx="62640" cy="5142240"/>
           </a:xfrm>
           <a:prstGeom prst="rect">
             <a:avLst/>
@@ -18866,7 +18872,7 @@
         <p:spPr>
           <a:xfrm>
             <a:off x="0" y="0"/>
-            <a:ext cx="9142920" cy="712080"/>
+            <a:ext cx="9142560" cy="711720"/>
           </a:xfrm>
           <a:prstGeom prst="rect">
             <a:avLst/>
@@ -18897,7 +18903,7 @@
         <p:spPr>
           <a:xfrm>
             <a:off x="182880" y="0"/>
-            <a:ext cx="7131240" cy="712080"/>
+            <a:ext cx="7130880" cy="711720"/>
           </a:xfrm>
           <a:prstGeom prst="rect">
             <a:avLst/>
@@ -18952,7 +18958,7 @@
         <p:spPr>
           <a:xfrm>
             <a:off x="7589520" y="109800"/>
-            <a:ext cx="1370520" cy="474480"/>
+            <a:ext cx="1370160" cy="474120"/>
           </a:xfrm>
           <a:prstGeom prst="rect">
             <a:avLst/>
@@ -18990,7 +18996,7 @@
         <p:spPr>
           <a:xfrm>
             <a:off x="7589520" y="109800"/>
-            <a:ext cx="1370520" cy="474480"/>
+            <a:ext cx="1370160" cy="474120"/>
           </a:xfrm>
           <a:prstGeom prst="rect">
             <a:avLst/>
@@ -20070,7 +20076,7 @@
         <p:spPr>
           <a:xfrm>
             <a:off x="182880" y="4462200"/>
-            <a:ext cx="4159440" cy="547560"/>
+            <a:ext cx="4159080" cy="547200"/>
           </a:xfrm>
           <a:prstGeom prst="rect">
             <a:avLst/>
@@ -20108,7 +20114,7 @@
         <p:spPr>
           <a:xfrm>
             <a:off x="320040" y="4526280"/>
-            <a:ext cx="3930840" cy="383040"/>
+            <a:ext cx="3930480" cy="382680"/>
           </a:xfrm>
           <a:prstGeom prst="rect">
             <a:avLst/>
@@ -20163,7 +20169,7 @@
         <p:spPr>
           <a:xfrm>
             <a:off x="4572000" y="4462200"/>
-            <a:ext cx="4388040" cy="547560"/>
+            <a:ext cx="4387680" cy="547200"/>
           </a:xfrm>
           <a:prstGeom prst="rect">
             <a:avLst/>
@@ -20201,7 +20207,7 @@
         <p:spPr>
           <a:xfrm>
             <a:off x="4709160" y="4526280"/>
-            <a:ext cx="4113720" cy="383040"/>
+            <a:ext cx="4113360" cy="382680"/>
           </a:xfrm>
           <a:prstGeom prst="rect">
             <a:avLst/>
@@ -20293,7 +20299,7 @@
         <p:spPr>
           <a:xfrm>
             <a:off x="0" y="0"/>
-            <a:ext cx="9142920" cy="5142600"/>
+            <a:ext cx="9142560" cy="5142240"/>
           </a:xfrm>
           <a:prstGeom prst="rect">
             <a:avLst/>
@@ -20326,7 +20332,7 @@
         <p:spPr>
           <a:xfrm>
             <a:off x="274320" y="457200"/>
-            <a:ext cx="2284920" cy="2742120"/>
+            <a:ext cx="2284560" cy="2741760"/>
           </a:xfrm>
           <a:prstGeom prst="rect">
             <a:avLst/>
@@ -20383,7 +20389,7 @@
         <p:spPr>
           <a:xfrm>
             <a:off x="1005840" y="1645920"/>
-            <a:ext cx="7131240" cy="53640"/>
+            <a:ext cx="7130880" cy="53280"/>
           </a:xfrm>
           <a:prstGeom prst="rect">
             <a:avLst/>
@@ -20414,7 +20420,7 @@
         <p:spPr>
           <a:xfrm>
             <a:off x="1005840" y="1783080"/>
-            <a:ext cx="7771320" cy="1370520"/>
+            <a:ext cx="7770960" cy="1370160"/>
           </a:xfrm>
           <a:prstGeom prst="rect">
             <a:avLst/>
@@ -20469,7 +20475,7 @@
         <p:spPr>
           <a:xfrm>
             <a:off x="1005840" y="3200400"/>
-            <a:ext cx="7771320" cy="821880"/>
+            <a:ext cx="7770960" cy="821520"/>
           </a:xfrm>
           <a:prstGeom prst="rect">
             <a:avLst/>

</xml_diff>